<commit_message>
Chore: update ppt and add report files - add shorter ppt version, modifiy presentation as per mentor guidance, update report and add summary
</commit_message>
<xml_diff>
--- a/deliverables/Capstone_Presentation.pptx
+++ b/deliverables/Capstone_Presentation.pptx
@@ -13,24 +13,24 @@
     <p:sldId id="258" r:id="rId4"/>
     <p:sldId id="259" r:id="rId5"/>
     <p:sldId id="260" r:id="rId6"/>
-    <p:sldId id="261" r:id="rId7"/>
-    <p:sldId id="262" r:id="rId8"/>
-    <p:sldId id="263" r:id="rId9"/>
-    <p:sldId id="264" r:id="rId10"/>
-    <p:sldId id="265" r:id="rId11"/>
     <p:sldId id="268" r:id="rId17"/>
     <p:sldId id="269" r:id="rId18"/>
     <p:sldId id="270" r:id="rId19"/>
     <p:sldId id="271" r:id="rId20"/>
     <p:sldId id="272" r:id="rId21"/>
+    <p:sldId id="261" r:id="rId7"/>
+    <p:sldId id="262" r:id="rId8"/>
     <p:sldId id="273" r:id="rId22"/>
     <p:sldId id="274" r:id="rId23"/>
     <p:sldId id="275" r:id="rId24"/>
+    <p:sldId id="263" r:id="rId9"/>
     <p:sldId id="276" r:id="rId25"/>
     <p:sldId id="277" r:id="rId26"/>
     <p:sldId id="278" r:id="rId27"/>
     <p:sldId id="279" r:id="rId28"/>
+    <p:sldId id="264" r:id="rId10"/>
     <p:sldId id="280" r:id="rId29"/>
+    <p:sldId id="265" r:id="rId11"/>
     <p:sldId id="281" r:id="rId30"/>
   </p:sldIdLst>
   <p:sldSz cx="9144000" cy="6858000" type="screen4x3"/>
@@ -10688,7 +10688,7 @@
                 </a:solidFill>
                 <a:latin typeface="Aptos"/>
               </a:rPr>
-              <a:t>150 sequences, 4,464 frames, drawn from three drives.</a:t>
+              <a:t>150 sequences, 4,526 frames, drawn from three drives.</a:t>
             </a:r>
           </a:p>
         </p:txBody>
@@ -10710,7 +10710,7 @@
         <p:spPr>
           <a:xfrm>
             <a:off x="475488" y="1554480"/>
-            <a:ext cx="8229600" cy="3298883"/>
+            <a:ext cx="8229600" cy="3320197"/>
           </a:xfrm>
           <a:prstGeom prst="rect">
             <a:avLst/>
@@ -11900,7 +11900,7 @@
         <p:spPr>
           <a:xfrm>
             <a:off x="475488" y="1554480"/>
-            <a:ext cx="4041648" cy="2834640"/>
+            <a:ext cx="2645664" cy="2834640"/>
           </a:xfrm>
           <a:prstGeom prst="roundRect">
             <a:avLst>
@@ -11953,7 +11953,7 @@
                 </a:solidFill>
                 <a:latin typeface="Aptos Display"/>
               </a:rPr>
-              <a:t>Objectives</a:t>
+              <a:t>Primary objectives</a:t>
             </a:r>
           </a:p>
           <a:p>
@@ -11985,7 +11985,7 @@
                 </a:solidFill>
                 <a:latin typeface="Aptos"/>
               </a:rPr>
-              <a:t>▪  Train a segmentation network on Indian road imagery</a:t>
+              <a:t>▪  Review lane detection and inference for Indian road settings</a:t>
             </a:r>
           </a:p>
           <a:p>
@@ -12001,7 +12001,7 @@
                 </a:solidFill>
                 <a:latin typeface="Aptos"/>
               </a:rPr>
-              <a:t>▪  Recover metric geometry with pitch measured, not assumed</a:t>
+              <a:t>▪  Infer lanes on structured, semi-structured and unstructured roads, from geometry rather than markings</a:t>
             </a:r>
           </a:p>
           <a:p>
@@ -12017,7 +12017,7 @@
                 </a:solidFill>
                 <a:latin typeface="Aptos"/>
               </a:rPr>
-              <a:t>▪  Infer a lane count from measured width and a design standard</a:t>
+              <a:t>▪  Make that model optimised, effective and lightweight enough for video rate on commodity hardware</a:t>
             </a:r>
           </a:p>
           <a:p>
@@ -12033,23 +12033,7 @@
                 </a:solidFill>
                 <a:latin typeface="Aptos"/>
               </a:rPr>
-              <a:t>▪  Report a confidence that predicts error</a:t>
-            </a:r>
-          </a:p>
-          <a:p>
-            <a:pPr>
-              <a:spcAft>
-                <a:spcPts val="600"/>
-              </a:spcAft>
-            </a:pPr>
-            <a:r>
-              <a:rPr sz="1100">
-                <a:solidFill>
-                  <a:srgbClr val="55606B"/>
-                </a:solidFill>
-                <a:latin typeface="Aptos"/>
-              </a:rPr>
-              <a:t>▪  Measure against baselines, including trivial ones</a:t>
+              <a:t>▪  Validate against ground truth and trivial baselines, with a confidence that predicts its own error</a:t>
             </a:r>
           </a:p>
         </p:txBody>
@@ -12106,8 +12090,8 @@
         </p:nvSpPr>
         <p:spPr>
           <a:xfrm>
-            <a:off x="4663440" y="1554480"/>
-            <a:ext cx="4041648" cy="2834640"/>
+            <a:off x="3267456" y="1554480"/>
+            <a:ext cx="2645664" cy="2834640"/>
           </a:xfrm>
           <a:prstGeom prst="roundRect">
             <a:avLst>
@@ -12160,7 +12144,7 @@
                 </a:solidFill>
                 <a:latin typeface="Aptos Display"/>
               </a:rPr>
-              <a:t>Scope</a:t>
+              <a:t>Secondary objectives</a:t>
             </a:r>
           </a:p>
           <a:p>
@@ -12176,7 +12160,7 @@
                 </a:solidFill>
                 <a:latin typeface="Aptos"/>
               </a:rPr>
-              <a:t>BOUNDARIES</a:t>
+              <a:t>ATTEMPTED, OUTCOMES REPORTED</a:t>
             </a:r>
           </a:p>
           <a:p>
@@ -12192,7 +12176,7 @@
                 </a:solidFill>
                 <a:latin typeface="Aptos"/>
               </a:rPr>
-              <a:t>▪  In: monocular forward-facing camera</a:t>
+              <a:t>▪  Wrong-side driving from inferred lane direction: implemented, unvalidated</a:t>
             </a:r>
           </a:p>
           <a:p>
@@ -12208,7 +12192,7 @@
                 </a:solidFill>
                 <a:latin typeface="Aptos"/>
               </a:rPr>
-              <a:t>▪  In: single image, video clip, live camera</a:t>
+              <a:t>▪  Traffic flow in unorganised conditions: measured and rejected</a:t>
             </a:r>
           </a:p>
           <a:p>
@@ -12224,71 +12208,7 @@
                 </a:solidFill>
                 <a:latin typeface="Aptos"/>
               </a:rPr>
-              <a:t>▪  In: lane count and metric widths, both validated</a:t>
-            </a:r>
-          </a:p>
-          <a:p>
-            <a:pPr>
-              <a:spcAft>
-                <a:spcPts val="600"/>
-              </a:spcAft>
-            </a:pPr>
-            <a:r>
-              <a:rPr sz="1100">
-                <a:solidFill>
-                  <a:srgbClr val="55606B"/>
-                </a:solidFill>
-                <a:latin typeface="Aptos"/>
-              </a:rPr>
-              <a:t>▪  Also reported, not validated: ego lane, road-user distances</a:t>
-            </a:r>
-          </a:p>
-          <a:p>
-            <a:pPr>
-              <a:spcAft>
-                <a:spcPts val="600"/>
-              </a:spcAft>
-            </a:pPr>
-            <a:r>
-              <a:rPr sz="1100">
-                <a:solidFill>
-                  <a:srgbClr val="55606B"/>
-                </a:solidFill>
-                <a:latin typeface="Aptos"/>
-              </a:rPr>
-              <a:t>▪  Out: path planning and vehicle control</a:t>
-            </a:r>
-          </a:p>
-          <a:p>
-            <a:pPr>
-              <a:spcAft>
-                <a:spcPts val="600"/>
-              </a:spcAft>
-            </a:pPr>
-            <a:r>
-              <a:rPr sz="1100">
-                <a:solidFill>
-                  <a:srgbClr val="55606B"/>
-                </a:solidFill>
-                <a:latin typeface="Aptos"/>
-              </a:rPr>
-              <a:t>▪  Out: any sensor other than the camera</a:t>
-            </a:r>
-          </a:p>
-          <a:p>
-            <a:pPr>
-              <a:spcAft>
-                <a:spcPts val="600"/>
-              </a:spcAft>
-            </a:pPr>
-            <a:r>
-              <a:rPr sz="1100">
-                <a:solidFill>
-                  <a:srgbClr val="55606B"/>
-                </a:solidFill>
-                <a:latin typeface="Aptos"/>
-              </a:rPr>
-              <a:t>▪  Out: night and heavy rain</a:t>
+              <a:t>▪  Feasibility for basic driver assistance: the limitations analysis</a:t>
             </a:r>
           </a:p>
         </p:txBody>
@@ -12301,7 +12221,7 @@
         </p:nvSpPr>
         <p:spPr>
           <a:xfrm>
-            <a:off x="4663440" y="1572768"/>
+            <a:off x="3267456" y="1572768"/>
             <a:ext cx="68580" cy="2798064"/>
           </a:xfrm>
           <a:prstGeom prst="rect">
@@ -12340,6 +12260,245 @@
       <p:sp>
         <p:nvSpPr>
           <p:cNvPr id="8" name="Rounded Rectangle 7"/>
+          <p:cNvSpPr/>
+          <p:nvPr/>
+        </p:nvSpPr>
+        <p:spPr>
+          <a:xfrm>
+            <a:off x="6059424" y="1554480"/>
+            <a:ext cx="2645664" cy="2834640"/>
+          </a:xfrm>
+          <a:prstGeom prst="roundRect">
+            <a:avLst>
+              <a:gd name="adj" fmla="val 3500"/>
+            </a:avLst>
+          </a:prstGeom>
+          <a:solidFill>
+            <a:srgbClr val="FFFFFF"/>
+          </a:solidFill>
+          <a:ln w="9525">
+            <a:solidFill>
+              <a:srgbClr val="DCE0E6"/>
+            </a:solidFill>
+          </a:ln>
+          <a:effectLst>
+            <a:outerShdw blurRad="76200" dist="20320" dir="2700000" rotWithShape="0">
+              <a:srgbClr val="2B3A4A">
+                <a:alpha val="22000"/>
+              </a:srgbClr>
+            </a:outerShdw>
+          </a:effectLst>
+        </p:spPr>
+        <p:style>
+          <a:lnRef idx="1">
+            <a:schemeClr val="accent1"/>
+          </a:lnRef>
+          <a:fillRef idx="3">
+            <a:schemeClr val="accent1"/>
+          </a:fillRef>
+          <a:effectRef idx="2">
+            <a:schemeClr val="accent1"/>
+          </a:effectRef>
+          <a:fontRef idx="minor">
+            <a:schemeClr val="lt1"/>
+          </a:fontRef>
+        </p:style>
+        <p:txBody>
+          <a:bodyPr rtlCol="0" anchor="t" wrap="square" lIns="214884" rIns="146304" tIns="128016" bIns="109728"/>
+          <a:lstStyle/>
+          <a:p>
+            <a:pPr>
+              <a:spcAft>
+                <a:spcPts val="400"/>
+              </a:spcAft>
+            </a:pPr>
+            <a:r>
+              <a:rPr sz="1450" b="1">
+                <a:solidFill>
+                  <a:srgbClr val="0A2E6E"/>
+                </a:solidFill>
+                <a:latin typeface="Aptos Display"/>
+              </a:rPr>
+              <a:t>Scope</a:t>
+            </a:r>
+          </a:p>
+          <a:p>
+            <a:pPr>
+              <a:spcAft>
+                <a:spcPts val="800"/>
+              </a:spcAft>
+            </a:pPr>
+            <a:r>
+              <a:rPr sz="850" b="1">
+                <a:solidFill>
+                  <a:srgbClr val="1668C0"/>
+                </a:solidFill>
+                <a:latin typeface="Aptos"/>
+              </a:rPr>
+              <a:t>BOUNDARIES</a:t>
+            </a:r>
+          </a:p>
+          <a:p>
+            <a:pPr>
+              <a:spcAft>
+                <a:spcPts val="600"/>
+              </a:spcAft>
+            </a:pPr>
+            <a:r>
+              <a:rPr sz="1100">
+                <a:solidFill>
+                  <a:srgbClr val="55606B"/>
+                </a:solidFill>
+                <a:latin typeface="Aptos"/>
+              </a:rPr>
+              <a:t>▪  In: monocular forward-facing camera</a:t>
+            </a:r>
+          </a:p>
+          <a:p>
+            <a:pPr>
+              <a:spcAft>
+                <a:spcPts val="600"/>
+              </a:spcAft>
+            </a:pPr>
+            <a:r>
+              <a:rPr sz="1100">
+                <a:solidFill>
+                  <a:srgbClr val="55606B"/>
+                </a:solidFill>
+                <a:latin typeface="Aptos"/>
+              </a:rPr>
+              <a:t>▪  In: single image, video clip, live camera</a:t>
+            </a:r>
+          </a:p>
+          <a:p>
+            <a:pPr>
+              <a:spcAft>
+                <a:spcPts val="600"/>
+              </a:spcAft>
+            </a:pPr>
+            <a:r>
+              <a:rPr sz="1100">
+                <a:solidFill>
+                  <a:srgbClr val="55606B"/>
+                </a:solidFill>
+                <a:latin typeface="Aptos"/>
+              </a:rPr>
+              <a:t>▪  In: lane count and metric widths, both validated</a:t>
+            </a:r>
+          </a:p>
+          <a:p>
+            <a:pPr>
+              <a:spcAft>
+                <a:spcPts val="600"/>
+              </a:spcAft>
+            </a:pPr>
+            <a:r>
+              <a:rPr sz="1100">
+                <a:solidFill>
+                  <a:srgbClr val="55606B"/>
+                </a:solidFill>
+                <a:latin typeface="Aptos"/>
+              </a:rPr>
+              <a:t>▪  Also reported, not validated: ego lane, road-user distances</a:t>
+            </a:r>
+          </a:p>
+          <a:p>
+            <a:pPr>
+              <a:spcAft>
+                <a:spcPts val="600"/>
+              </a:spcAft>
+            </a:pPr>
+            <a:r>
+              <a:rPr sz="1100">
+                <a:solidFill>
+                  <a:srgbClr val="55606B"/>
+                </a:solidFill>
+                <a:latin typeface="Aptos"/>
+              </a:rPr>
+              <a:t>▪  Out: path planning and vehicle control</a:t>
+            </a:r>
+          </a:p>
+          <a:p>
+            <a:pPr>
+              <a:spcAft>
+                <a:spcPts val="600"/>
+              </a:spcAft>
+            </a:pPr>
+            <a:r>
+              <a:rPr sz="1100">
+                <a:solidFill>
+                  <a:srgbClr val="55606B"/>
+                </a:solidFill>
+                <a:latin typeface="Aptos"/>
+              </a:rPr>
+              <a:t>▪  Out: any sensor other than the camera</a:t>
+            </a:r>
+          </a:p>
+          <a:p>
+            <a:pPr>
+              <a:spcAft>
+                <a:spcPts val="600"/>
+              </a:spcAft>
+            </a:pPr>
+            <a:r>
+              <a:rPr sz="1100">
+                <a:solidFill>
+                  <a:srgbClr val="55606B"/>
+                </a:solidFill>
+                <a:latin typeface="Aptos"/>
+              </a:rPr>
+              <a:t>▪  Out: night and heavy rain</a:t>
+            </a:r>
+          </a:p>
+        </p:txBody>
+      </p:sp>
+      <p:sp>
+        <p:nvSpPr>
+          <p:cNvPr id="9" name="Rectangle 8"/>
+          <p:cNvSpPr/>
+          <p:nvPr/>
+        </p:nvSpPr>
+        <p:spPr>
+          <a:xfrm>
+            <a:off x="6059424" y="1572768"/>
+            <a:ext cx="68580" cy="2798064"/>
+          </a:xfrm>
+          <a:prstGeom prst="rect">
+            <a:avLst/>
+          </a:prstGeom>
+          <a:solidFill>
+            <a:srgbClr val="0A2E6E"/>
+          </a:solidFill>
+          <a:ln>
+            <a:noFill/>
+          </a:ln>
+          <a:effectLst/>
+        </p:spPr>
+        <p:style>
+          <a:lnRef idx="1">
+            <a:schemeClr val="accent1"/>
+          </a:lnRef>
+          <a:fillRef idx="3">
+            <a:schemeClr val="accent1"/>
+          </a:fillRef>
+          <a:effectRef idx="2">
+            <a:schemeClr val="accent1"/>
+          </a:effectRef>
+          <a:fontRef idx="minor">
+            <a:schemeClr val="lt1"/>
+          </a:fontRef>
+        </p:style>
+        <p:txBody>
+          <a:bodyPr rtlCol="0" anchor="ctr"/>
+          <a:lstStyle/>
+          <a:p>
+            <a:pPr algn="ctr"/>
+          </a:p>
+        </p:txBody>
+      </p:sp>
+      <p:sp>
+        <p:nvSpPr>
+          <p:cNvPr id="10" name="Rounded Rectangle 9"/>
           <p:cNvSpPr/>
           <p:nvPr/>
         </p:nvSpPr>
@@ -12387,7 +12546,7 @@
       </p:sp>
       <p:sp>
         <p:nvSpPr>
-          <p:cNvPr id="9" name="TextBox 8"/>
+          <p:cNvPr id="11" name="TextBox 10"/>
           <p:cNvSpPr txBox="1"/>
           <p:nvPr/>
         </p:nvSpPr>
@@ -12421,7 +12580,7 @@
       </p:sp>
       <p:sp>
         <p:nvSpPr>
-          <p:cNvPr id="10" name="Rounded Rectangle 9"/>
+          <p:cNvPr id="12" name="Rounded Rectangle 11"/>
           <p:cNvSpPr/>
           <p:nvPr/>
         </p:nvSpPr>
@@ -12484,7 +12643,7 @@
       </p:sp>
       <p:sp>
         <p:nvSpPr>
-          <p:cNvPr id="11" name="Rounded Rectangle 10"/>
+          <p:cNvPr id="13" name="Rounded Rectangle 12"/>
           <p:cNvSpPr/>
           <p:nvPr/>
         </p:nvSpPr>
@@ -12547,7 +12706,7 @@
       </p:sp>
       <p:sp>
         <p:nvSpPr>
-          <p:cNvPr id="12" name="Rounded Rectangle 11"/>
+          <p:cNvPr id="14" name="Rounded Rectangle 13"/>
           <p:cNvSpPr/>
           <p:nvPr/>
         </p:nvSpPr>
@@ -12610,7 +12769,7 @@
       </p:sp>
       <p:sp>
         <p:nvSpPr>
-          <p:cNvPr id="13" name="Rounded Rectangle 12"/>
+          <p:cNvPr id="15" name="Rounded Rectangle 14"/>
           <p:cNvSpPr/>
           <p:nvPr/>
         </p:nvSpPr>
@@ -12673,7 +12832,7 @@
       </p:sp>
       <p:sp>
         <p:nvSpPr>
-          <p:cNvPr id="14" name="Rounded Rectangle 13"/>
+          <p:cNvPr id="16" name="Rounded Rectangle 15"/>
           <p:cNvSpPr/>
           <p:nvPr/>
         </p:nvSpPr>
@@ -12736,7 +12895,7 @@
       </p:sp>
       <p:sp>
         <p:nvSpPr>
-          <p:cNvPr id="15" name="Rounded Rectangle 14"/>
+          <p:cNvPr id="17" name="Rounded Rectangle 16"/>
           <p:cNvSpPr/>
           <p:nvPr/>
         </p:nvSpPr>
@@ -12799,7 +12958,7 @@
       </p:sp>
       <p:sp>
         <p:nvSpPr>
-          <p:cNvPr id="16" name="Rounded Rectangle 15"/>
+          <p:cNvPr id="18" name="Rounded Rectangle 17"/>
           <p:cNvSpPr/>
           <p:nvPr/>
         </p:nvSpPr>

</xml_diff>